<commit_message>
Actualizar precios: 500k+10% / 400k+15%
</commit_message>
<xml_diff>
--- a/propuesta-raul-ferrari.pptx
+++ b/propuesta-raul-ferrari.pptx
@@ -9917,7 +9917,7 @@
                 </a:solidFill>
                 <a:latin typeface="Georgia"/>
               </a:rPr>
-              <a:t>$400.000</a:t>
+              <a:t>$500.000</a:t>
             </a:r>
           </a:p>
         </p:txBody>
@@ -10363,7 +10363,7 @@
                 </a:solidFill>
                 <a:latin typeface="Segoe UI"/>
               </a:rPr>
-              <a:t>$300.000 de honorario + 15% sobre esas ventas.</a:t>
+              <a:t>$400.000 de honorario + 15% sobre esas ventas.</a:t>
             </a:r>
           </a:p>
         </p:txBody>

</xml_diff>